<commit_message>
feat: add QR to ER diagram HTML and update pptx QR to point to er-diagram-nuevo.html
- er-diagram-nuevo.html: fixed QR card in bottom-left corner linking to Railway URL
- generar_pptx.py: QR now points to /er-diagram-nuevo.html instead of /db-schema.html
- Hipodromo_Nacional.pptx: regenerated with updated QR

Co-Authored-By: Claude Sonnet 4.6 <noreply@anthropic.com>
</commit_message>
<xml_diff>
--- a/Hipodromo_Nacional.pptx
+++ b/Hipodromo_Nacional.pptx
@@ -18,6 +18,7 @@
     <p:sldId id="266" r:id="rId17"/>
     <p:sldId id="267" r:id="rId18"/>
     <p:sldId id="268" r:id="rId19"/>
+    <p:sldId id="269" r:id="rId20"/>
   </p:sldIdLst>
   <p:sldSz cx="12188952" cy="6858000" type="screen4x3"/>
   <p:notesSz cx="6858000" cy="9144000"/>
@@ -3860,7 +3861,7 @@
                   <a:srgbClr val="8B949E"/>
                 </a:solidFill>
               </a:rPr>
-              <a:t>1 / 13</a:t>
+              <a:t>1 / 14</a:t>
             </a:r>
           </a:p>
         </p:txBody>
@@ -4074,7 +4075,7 @@
                   <a:srgbClr val="8B949E"/>
                 </a:solidFill>
               </a:rPr>
-              <a:t>10 / 13</a:t>
+              <a:t>10 / 14</a:t>
             </a:r>
           </a:p>
         </p:txBody>
@@ -5292,7 +5293,7 @@
                   <a:srgbClr val="8B949E"/>
                 </a:solidFill>
               </a:rPr>
-              <a:t>11 / 13</a:t>
+              <a:t>11 / 14</a:t>
             </a:r>
           </a:p>
         </p:txBody>
@@ -7762,7 +7763,7 @@
                   <a:srgbClr val="8B949E"/>
                 </a:solidFill>
               </a:rPr>
-              <a:t>12 / 13</a:t>
+              <a:t>12 / 14</a:t>
             </a:r>
           </a:p>
         </p:txBody>
@@ -10187,7 +10188,41 @@
       </p:pic>
       <p:sp>
         <p:nvSpPr>
-          <p:cNvPr id="34" name="Rectangle 33"/>
+          <p:cNvPr id="34" name="TextBox 33"/>
+          <p:cNvSpPr txBox="1"/>
+          <p:nvPr/>
+        </p:nvSpPr>
+        <p:spPr>
+          <a:xfrm>
+            <a:off x="9326880" y="3493008"/>
+            <a:ext cx="2423160" cy="256032"/>
+          </a:xfrm>
+          <a:prstGeom prst="rect">
+            <a:avLst/>
+          </a:prstGeom>
+          <a:noFill/>
+        </p:spPr>
+        <p:txBody>
+          <a:bodyPr wrap="square">
+            <a:spAutoFit/>
+          </a:bodyPr>
+          <a:lstStyle/>
+          <a:p>
+            <a:pPr algn="ctr"/>
+            <a:r>
+              <a:rPr sz="650" b="0">
+                <a:solidFill>
+                  <a:srgbClr val="8B949E"/>
+                </a:solidFill>
+              </a:rPr>
+              <a:t>hipodromonacional-production.up.railway.app</a:t>
+            </a:r>
+          </a:p>
+        </p:txBody>
+      </p:sp>
+      <p:sp>
+        <p:nvSpPr>
+          <p:cNvPr id="35" name="Rectangle 34"/>
           <p:cNvSpPr/>
           <p:nvPr/>
         </p:nvSpPr>
@@ -10230,7 +10265,7 @@
       </p:sp>
       <p:sp>
         <p:nvSpPr>
-          <p:cNvPr id="35" name="TextBox 34"/>
+          <p:cNvPr id="36" name="TextBox 35"/>
           <p:cNvSpPr txBox="1"/>
           <p:nvPr/>
         </p:nvSpPr>
@@ -10264,7 +10299,7 @@
       </p:sp>
       <p:sp>
         <p:nvSpPr>
-          <p:cNvPr id="36" name="TextBox 35"/>
+          <p:cNvPr id="37" name="TextBox 36"/>
           <p:cNvSpPr txBox="1"/>
           <p:nvPr/>
         </p:nvSpPr>
@@ -10298,7 +10333,7 @@
       </p:sp>
       <p:sp>
         <p:nvSpPr>
-          <p:cNvPr id="37" name="TextBox 36"/>
+          <p:cNvPr id="38" name="TextBox 37"/>
           <p:cNvSpPr txBox="1"/>
           <p:nvPr/>
         </p:nvSpPr>
@@ -10325,7 +10360,2608 @@
                   <a:srgbClr val="8B949E"/>
                 </a:solidFill>
               </a:rPr>
-              <a:t>13 / 13</a:t>
+              <a:t>13 / 14</a:t>
+            </a:r>
+          </a:p>
+        </p:txBody>
+      </p:sp>
+    </p:spTree>
+  </p:cSld>
+  <p:clrMapOvr>
+    <a:masterClrMapping/>
+  </p:clrMapOvr>
+</p:sld>
+</file>
+
+<file path=ppt/slides/slide14.xml><?xml version="1.0" encoding="utf-8"?>
+<p:sld xmlns:a="http://schemas.openxmlformats.org/drawingml/2006/main" xmlns:p="http://schemas.openxmlformats.org/presentationml/2006/main" xmlns:r="http://schemas.openxmlformats.org/officeDocument/2006/relationships">
+  <p:cSld>
+    <p:bg>
+      <p:bgPr>
+        <a:solidFill>
+          <a:srgbClr val="0D1117"/>
+        </a:solidFill>
+        <a:effectLst/>
+      </p:bgPr>
+    </p:bg>
+    <p:spTree>
+      <p:nvGrpSpPr>
+        <p:cNvPr id="1" name=""/>
+        <p:cNvGrpSpPr/>
+        <p:nvPr/>
+      </p:nvGrpSpPr>
+      <p:grpSpPr/>
+      <p:sp>
+        <p:nvSpPr>
+          <p:cNvPr id="2" name="Rectangle 1"/>
+          <p:cNvSpPr/>
+          <p:nvPr/>
+        </p:nvSpPr>
+        <p:spPr>
+          <a:xfrm>
+            <a:off x="0" y="0"/>
+            <a:ext cx="12188952" cy="50800"/>
+          </a:xfrm>
+          <a:prstGeom prst="rect">
+            <a:avLst/>
+          </a:prstGeom>
+          <a:solidFill>
+            <a:srgbClr val="FFD700"/>
+          </a:solidFill>
+          <a:ln>
+            <a:noFill/>
+          </a:ln>
+        </p:spPr>
+        <p:style>
+          <a:lnRef idx="1">
+            <a:schemeClr val="accent1"/>
+          </a:lnRef>
+          <a:fillRef idx="3">
+            <a:schemeClr val="accent1"/>
+          </a:fillRef>
+          <a:effectRef idx="2">
+            <a:schemeClr val="accent1"/>
+          </a:effectRef>
+          <a:fontRef idx="minor">
+            <a:schemeClr val="lt1"/>
+          </a:fontRef>
+        </p:style>
+        <p:txBody>
+          <a:bodyPr rtlCol="0" anchor="ctr"/>
+          <a:lstStyle/>
+          <a:p>
+            <a:pPr algn="ctr"/>
+          </a:p>
+        </p:txBody>
+      </p:sp>
+      <p:sp>
+        <p:nvSpPr>
+          <p:cNvPr id="3" name="Rectangle 2"/>
+          <p:cNvSpPr/>
+          <p:nvPr/>
+        </p:nvSpPr>
+        <p:spPr>
+          <a:xfrm>
+            <a:off x="0" y="0"/>
+            <a:ext cx="12188952" cy="384048"/>
+          </a:xfrm>
+          <a:prstGeom prst="rect">
+            <a:avLst/>
+          </a:prstGeom>
+          <a:solidFill>
+            <a:srgbClr val="0A0E14"/>
+          </a:solidFill>
+          <a:ln>
+            <a:noFill/>
+          </a:ln>
+        </p:spPr>
+        <p:style>
+          <a:lnRef idx="1">
+            <a:schemeClr val="accent1"/>
+          </a:lnRef>
+          <a:fillRef idx="3">
+            <a:schemeClr val="accent1"/>
+          </a:fillRef>
+          <a:effectRef idx="2">
+            <a:schemeClr val="accent1"/>
+          </a:effectRef>
+          <a:fontRef idx="minor">
+            <a:schemeClr val="lt1"/>
+          </a:fontRef>
+        </p:style>
+        <p:txBody>
+          <a:bodyPr rtlCol="0" anchor="ctr"/>
+          <a:lstStyle/>
+          <a:p>
+            <a:pPr algn="ctr"/>
+          </a:p>
+        </p:txBody>
+      </p:sp>
+      <p:sp>
+        <p:nvSpPr>
+          <p:cNvPr id="4" name="TextBox 3"/>
+          <p:cNvSpPr txBox="1"/>
+          <p:nvPr/>
+        </p:nvSpPr>
+        <p:spPr>
+          <a:xfrm>
+            <a:off x="0" y="0"/>
+            <a:ext cx="12188952" cy="384048"/>
+          </a:xfrm>
+          <a:prstGeom prst="rect">
+            <a:avLst/>
+          </a:prstGeom>
+          <a:noFill/>
+        </p:spPr>
+        <p:txBody>
+          <a:bodyPr wrap="square">
+            <a:spAutoFit/>
+          </a:bodyPr>
+          <a:lstStyle/>
+          <a:p>
+            <a:pPr algn="ctr"/>
+            <a:r>
+              <a:rPr sz="1400" b="1">
+                <a:solidFill>
+                  <a:srgbClr val="FFD700"/>
+                </a:solidFill>
+              </a:rPr>
+              <a:t>Diagrama Entidad-Relación  —  19 tablas</a:t>
+            </a:r>
+          </a:p>
+        </p:txBody>
+      </p:sp>
+      <p:sp>
+        <p:nvSpPr>
+          <p:cNvPr id="5" name="Rectangle 4"/>
+          <p:cNvSpPr/>
+          <p:nvPr/>
+        </p:nvSpPr>
+        <p:spPr>
+          <a:xfrm>
+            <a:off x="182880" y="475488"/>
+            <a:ext cx="731520" cy="260603"/>
+          </a:xfrm>
+          <a:prstGeom prst="rect">
+            <a:avLst/>
+          </a:prstGeom>
+          <a:solidFill>
+            <a:srgbClr val="092010"/>
+          </a:solidFill>
+          <a:ln w="12700">
+            <a:solidFill>
+              <a:srgbClr val="3FB950"/>
+            </a:solidFill>
+          </a:ln>
+        </p:spPr>
+        <p:style>
+          <a:lnRef idx="1">
+            <a:schemeClr val="accent1"/>
+          </a:lnRef>
+          <a:fillRef idx="3">
+            <a:schemeClr val="accent1"/>
+          </a:fillRef>
+          <a:effectRef idx="2">
+            <a:schemeClr val="accent1"/>
+          </a:effectRef>
+          <a:fontRef idx="minor">
+            <a:schemeClr val="lt1"/>
+          </a:fontRef>
+        </p:style>
+        <p:txBody>
+          <a:bodyPr rtlCol="0" anchor="ctr"/>
+          <a:lstStyle/>
+          <a:p>
+            <a:pPr algn="ctr"/>
+          </a:p>
+        </p:txBody>
+      </p:sp>
+      <p:sp>
+        <p:nvSpPr>
+          <p:cNvPr id="6" name="TextBox 5"/>
+          <p:cNvSpPr txBox="1"/>
+          <p:nvPr/>
+        </p:nvSpPr>
+        <p:spPr>
+          <a:xfrm>
+            <a:off x="182880" y="475488"/>
+            <a:ext cx="731520" cy="260603"/>
+          </a:xfrm>
+          <a:prstGeom prst="rect">
+            <a:avLst/>
+          </a:prstGeom>
+          <a:noFill/>
+        </p:spPr>
+        <p:txBody>
+          <a:bodyPr wrap="square">
+            <a:spAutoFit/>
+          </a:bodyPr>
+          <a:lstStyle/>
+          <a:p>
+            <a:pPr algn="ctr"/>
+            <a:r>
+              <a:rPr sz="700" b="1">
+                <a:solidFill>
+                  <a:srgbClr val="F0F6FC"/>
+                </a:solidFill>
+              </a:rPr>
+              <a:t>pais</a:t>
+            </a:r>
+          </a:p>
+        </p:txBody>
+      </p:sp>
+      <p:sp>
+        <p:nvSpPr>
+          <p:cNvPr id="7" name="Rectangle 6"/>
+          <p:cNvSpPr/>
+          <p:nvPr/>
+        </p:nvSpPr>
+        <p:spPr>
+          <a:xfrm>
+            <a:off x="1033271" y="475488"/>
+            <a:ext cx="987552" cy="260603"/>
+          </a:xfrm>
+          <a:prstGeom prst="rect">
+            <a:avLst/>
+          </a:prstGeom>
+          <a:solidFill>
+            <a:srgbClr val="092010"/>
+          </a:solidFill>
+          <a:ln w="12700">
+            <a:solidFill>
+              <a:srgbClr val="3FB950"/>
+            </a:solidFill>
+          </a:ln>
+        </p:spPr>
+        <p:style>
+          <a:lnRef idx="1">
+            <a:schemeClr val="accent1"/>
+          </a:lnRef>
+          <a:fillRef idx="3">
+            <a:schemeClr val="accent1"/>
+          </a:fillRef>
+          <a:effectRef idx="2">
+            <a:schemeClr val="accent1"/>
+          </a:effectRef>
+          <a:fontRef idx="minor">
+            <a:schemeClr val="lt1"/>
+          </a:fontRef>
+        </p:style>
+        <p:txBody>
+          <a:bodyPr rtlCol="0" anchor="ctr"/>
+          <a:lstStyle/>
+          <a:p>
+            <a:pPr algn="ctr"/>
+          </a:p>
+        </p:txBody>
+      </p:sp>
+      <p:sp>
+        <p:nvSpPr>
+          <p:cNvPr id="8" name="TextBox 7"/>
+          <p:cNvSpPr txBox="1"/>
+          <p:nvPr/>
+        </p:nvSpPr>
+        <p:spPr>
+          <a:xfrm>
+            <a:off x="1033271" y="475488"/>
+            <a:ext cx="987552" cy="260603"/>
+          </a:xfrm>
+          <a:prstGeom prst="rect">
+            <a:avLst/>
+          </a:prstGeom>
+          <a:noFill/>
+        </p:spPr>
+        <p:txBody>
+          <a:bodyPr wrap="square">
+            <a:spAutoFit/>
+          </a:bodyPr>
+          <a:lstStyle/>
+          <a:p>
+            <a:pPr algn="ctr"/>
+            <a:r>
+              <a:rPr sz="700" b="1">
+                <a:solidFill>
+                  <a:srgbClr val="F0F6FC"/>
+                </a:solidFill>
+              </a:rPr>
+              <a:t>provincia</a:t>
+            </a:r>
+          </a:p>
+        </p:txBody>
+      </p:sp>
+      <p:sp>
+        <p:nvSpPr>
+          <p:cNvPr id="9" name="Rectangle 8"/>
+          <p:cNvSpPr/>
+          <p:nvPr/>
+        </p:nvSpPr>
+        <p:spPr>
+          <a:xfrm>
+            <a:off x="2139696" y="475488"/>
+            <a:ext cx="804672" cy="260603"/>
+          </a:xfrm>
+          <a:prstGeom prst="rect">
+            <a:avLst/>
+          </a:prstGeom>
+          <a:solidFill>
+            <a:srgbClr val="092010"/>
+          </a:solidFill>
+          <a:ln w="12700">
+            <a:solidFill>
+              <a:srgbClr val="3FB950"/>
+            </a:solidFill>
+          </a:ln>
+        </p:spPr>
+        <p:style>
+          <a:lnRef idx="1">
+            <a:schemeClr val="accent1"/>
+          </a:lnRef>
+          <a:fillRef idx="3">
+            <a:schemeClr val="accent1"/>
+          </a:fillRef>
+          <a:effectRef idx="2">
+            <a:schemeClr val="accent1"/>
+          </a:effectRef>
+          <a:fontRef idx="minor">
+            <a:schemeClr val="lt1"/>
+          </a:fontRef>
+        </p:style>
+        <p:txBody>
+          <a:bodyPr rtlCol="0" anchor="ctr"/>
+          <a:lstStyle/>
+          <a:p>
+            <a:pPr algn="ctr"/>
+          </a:p>
+        </p:txBody>
+      </p:sp>
+      <p:sp>
+        <p:nvSpPr>
+          <p:cNvPr id="10" name="TextBox 9"/>
+          <p:cNvSpPr txBox="1"/>
+          <p:nvPr/>
+        </p:nvSpPr>
+        <p:spPr>
+          <a:xfrm>
+            <a:off x="2139696" y="475488"/>
+            <a:ext cx="804672" cy="260603"/>
+          </a:xfrm>
+          <a:prstGeom prst="rect">
+            <a:avLst/>
+          </a:prstGeom>
+          <a:noFill/>
+        </p:spPr>
+        <p:txBody>
+          <a:bodyPr wrap="square">
+            <a:spAutoFit/>
+          </a:bodyPr>
+          <a:lstStyle/>
+          <a:p>
+            <a:pPr algn="ctr"/>
+            <a:r>
+              <a:rPr sz="700" b="1">
+                <a:solidFill>
+                  <a:srgbClr val="F0F6FC"/>
+                </a:solidFill>
+              </a:rPr>
+              <a:t>canton</a:t>
+            </a:r>
+          </a:p>
+        </p:txBody>
+      </p:sp>
+      <p:sp>
+        <p:nvSpPr>
+          <p:cNvPr id="11" name="Rectangle 10"/>
+          <p:cNvSpPr/>
+          <p:nvPr/>
+        </p:nvSpPr>
+        <p:spPr>
+          <a:xfrm>
+            <a:off x="3063240" y="475488"/>
+            <a:ext cx="804672" cy="260603"/>
+          </a:xfrm>
+          <a:prstGeom prst="rect">
+            <a:avLst/>
+          </a:prstGeom>
+          <a:solidFill>
+            <a:srgbClr val="092010"/>
+          </a:solidFill>
+          <a:ln w="12700">
+            <a:solidFill>
+              <a:srgbClr val="3FB950"/>
+            </a:solidFill>
+          </a:ln>
+        </p:spPr>
+        <p:style>
+          <a:lnRef idx="1">
+            <a:schemeClr val="accent1"/>
+          </a:lnRef>
+          <a:fillRef idx="3">
+            <a:schemeClr val="accent1"/>
+          </a:fillRef>
+          <a:effectRef idx="2">
+            <a:schemeClr val="accent1"/>
+          </a:effectRef>
+          <a:fontRef idx="minor">
+            <a:schemeClr val="lt1"/>
+          </a:fontRef>
+        </p:style>
+        <p:txBody>
+          <a:bodyPr rtlCol="0" anchor="ctr"/>
+          <a:lstStyle/>
+          <a:p>
+            <a:pPr algn="ctr"/>
+          </a:p>
+        </p:txBody>
+      </p:sp>
+      <p:sp>
+        <p:nvSpPr>
+          <p:cNvPr id="12" name="TextBox 11"/>
+          <p:cNvSpPr txBox="1"/>
+          <p:nvPr/>
+        </p:nvSpPr>
+        <p:spPr>
+          <a:xfrm>
+            <a:off x="3063240" y="475488"/>
+            <a:ext cx="804672" cy="260603"/>
+          </a:xfrm>
+          <a:prstGeom prst="rect">
+            <a:avLst/>
+          </a:prstGeom>
+          <a:noFill/>
+        </p:spPr>
+        <p:txBody>
+          <a:bodyPr wrap="square">
+            <a:spAutoFit/>
+          </a:bodyPr>
+          <a:lstStyle/>
+          <a:p>
+            <a:pPr algn="ctr"/>
+            <a:r>
+              <a:rPr sz="700" b="1">
+                <a:solidFill>
+                  <a:srgbClr val="F0F6FC"/>
+                </a:solidFill>
+              </a:rPr>
+              <a:t>distrito</a:t>
+            </a:r>
+          </a:p>
+        </p:txBody>
+      </p:sp>
+      <p:sp>
+        <p:nvSpPr>
+          <p:cNvPr id="13" name="Rectangle 12"/>
+          <p:cNvSpPr/>
+          <p:nvPr/>
+        </p:nvSpPr>
+        <p:spPr>
+          <a:xfrm>
+            <a:off x="3986784" y="475488"/>
+            <a:ext cx="749808" cy="260603"/>
+          </a:xfrm>
+          <a:prstGeom prst="rect">
+            <a:avLst/>
+          </a:prstGeom>
+          <a:solidFill>
+            <a:srgbClr val="092010"/>
+          </a:solidFill>
+          <a:ln w="12700">
+            <a:solidFill>
+              <a:srgbClr val="3FB950"/>
+            </a:solidFill>
+          </a:ln>
+        </p:spPr>
+        <p:style>
+          <a:lnRef idx="1">
+            <a:schemeClr val="accent1"/>
+          </a:lnRef>
+          <a:fillRef idx="3">
+            <a:schemeClr val="accent1"/>
+          </a:fillRef>
+          <a:effectRef idx="2">
+            <a:schemeClr val="accent1"/>
+          </a:effectRef>
+          <a:fontRef idx="minor">
+            <a:schemeClr val="lt1"/>
+          </a:fontRef>
+        </p:style>
+        <p:txBody>
+          <a:bodyPr rtlCol="0" anchor="ctr"/>
+          <a:lstStyle/>
+          <a:p>
+            <a:pPr algn="ctr"/>
+          </a:p>
+        </p:txBody>
+      </p:sp>
+      <p:sp>
+        <p:nvSpPr>
+          <p:cNvPr id="14" name="TextBox 13"/>
+          <p:cNvSpPr txBox="1"/>
+          <p:nvPr/>
+        </p:nvSpPr>
+        <p:spPr>
+          <a:xfrm>
+            <a:off x="3986784" y="475488"/>
+            <a:ext cx="749808" cy="260603"/>
+          </a:xfrm>
+          <a:prstGeom prst="rect">
+            <a:avLst/>
+          </a:prstGeom>
+          <a:noFill/>
+        </p:spPr>
+        <p:txBody>
+          <a:bodyPr wrap="square">
+            <a:spAutoFit/>
+          </a:bodyPr>
+          <a:lstStyle/>
+          <a:p>
+            <a:pPr algn="ctr"/>
+            <a:r>
+              <a:rPr sz="700" b="1">
+                <a:solidFill>
+                  <a:srgbClr val="F0F6FC"/>
+                </a:solidFill>
+              </a:rPr>
+              <a:t>barrio</a:t>
+            </a:r>
+          </a:p>
+        </p:txBody>
+      </p:sp>
+      <p:cxnSp>
+        <p:nvCxnSpPr>
+          <p:cNvPr id="15" name="Connector 14"/>
+          <p:cNvCxnSpPr/>
+          <p:nvPr/>
+        </p:nvCxnSpPr>
+        <p:spPr>
+          <a:xfrm>
+            <a:off x="914400" y="605332"/>
+            <a:ext cx="118871" cy="0"/>
+          </a:xfrm>
+          <a:prstGeom prst="line">
+            <a:avLst/>
+          </a:prstGeom>
+          <a:ln w="10160">
+            <a:solidFill>
+              <a:srgbClr val="3FB950"/>
+            </a:solidFill>
+          </a:ln>
+        </p:spPr>
+        <p:style>
+          <a:lnRef idx="2">
+            <a:schemeClr val="accent1"/>
+          </a:lnRef>
+          <a:fillRef idx="0">
+            <a:schemeClr val="accent1"/>
+          </a:fillRef>
+          <a:effectRef idx="1">
+            <a:schemeClr val="accent1"/>
+          </a:effectRef>
+          <a:fontRef idx="minor">
+            <a:schemeClr val="tx1"/>
+          </a:fontRef>
+        </p:style>
+      </p:cxnSp>
+      <p:cxnSp>
+        <p:nvCxnSpPr>
+          <p:cNvPr id="16" name="Connector 15"/>
+          <p:cNvCxnSpPr/>
+          <p:nvPr/>
+        </p:nvCxnSpPr>
+        <p:spPr>
+          <a:xfrm>
+            <a:off x="2020824" y="605332"/>
+            <a:ext cx="118872" cy="0"/>
+          </a:xfrm>
+          <a:prstGeom prst="line">
+            <a:avLst/>
+          </a:prstGeom>
+          <a:ln w="10160">
+            <a:solidFill>
+              <a:srgbClr val="3FB950"/>
+            </a:solidFill>
+          </a:ln>
+        </p:spPr>
+        <p:style>
+          <a:lnRef idx="2">
+            <a:schemeClr val="accent1"/>
+          </a:lnRef>
+          <a:fillRef idx="0">
+            <a:schemeClr val="accent1"/>
+          </a:fillRef>
+          <a:effectRef idx="1">
+            <a:schemeClr val="accent1"/>
+          </a:effectRef>
+          <a:fontRef idx="minor">
+            <a:schemeClr val="tx1"/>
+          </a:fontRef>
+        </p:style>
+      </p:cxnSp>
+      <p:cxnSp>
+        <p:nvCxnSpPr>
+          <p:cNvPr id="17" name="Connector 16"/>
+          <p:cNvCxnSpPr/>
+          <p:nvPr/>
+        </p:nvCxnSpPr>
+        <p:spPr>
+          <a:xfrm>
+            <a:off x="2953512" y="605332"/>
+            <a:ext cx="109728" cy="0"/>
+          </a:xfrm>
+          <a:prstGeom prst="line">
+            <a:avLst/>
+          </a:prstGeom>
+          <a:ln w="10160">
+            <a:solidFill>
+              <a:srgbClr val="3FB950"/>
+            </a:solidFill>
+          </a:ln>
+        </p:spPr>
+        <p:style>
+          <a:lnRef idx="2">
+            <a:schemeClr val="accent1"/>
+          </a:lnRef>
+          <a:fillRef idx="0">
+            <a:schemeClr val="accent1"/>
+          </a:fillRef>
+          <a:effectRef idx="1">
+            <a:schemeClr val="accent1"/>
+          </a:effectRef>
+          <a:fontRef idx="minor">
+            <a:schemeClr val="tx1"/>
+          </a:fontRef>
+        </p:style>
+      </p:cxnSp>
+      <p:cxnSp>
+        <p:nvCxnSpPr>
+          <p:cNvPr id="18" name="Connector 17"/>
+          <p:cNvCxnSpPr/>
+          <p:nvPr/>
+        </p:nvCxnSpPr>
+        <p:spPr>
+          <a:xfrm>
+            <a:off x="3867912" y="605332"/>
+            <a:ext cx="118872" cy="0"/>
+          </a:xfrm>
+          <a:prstGeom prst="line">
+            <a:avLst/>
+          </a:prstGeom>
+          <a:ln w="10160">
+            <a:solidFill>
+              <a:srgbClr val="3FB950"/>
+            </a:solidFill>
+          </a:ln>
+        </p:spPr>
+        <p:style>
+          <a:lnRef idx="2">
+            <a:schemeClr val="accent1"/>
+          </a:lnRef>
+          <a:fillRef idx="0">
+            <a:schemeClr val="accent1"/>
+          </a:fillRef>
+          <a:effectRef idx="1">
+            <a:schemeClr val="accent1"/>
+          </a:effectRef>
+          <a:fontRef idx="minor">
+            <a:schemeClr val="tx1"/>
+          </a:fontRef>
+        </p:style>
+      </p:cxnSp>
+      <p:sp>
+        <p:nvSpPr>
+          <p:cNvPr id="19" name="Rectangle 18"/>
+          <p:cNvSpPr/>
+          <p:nvPr/>
+        </p:nvSpPr>
+        <p:spPr>
+          <a:xfrm>
+            <a:off x="182880" y="1280160"/>
+            <a:ext cx="1234440" cy="260603"/>
+          </a:xfrm>
+          <a:prstGeom prst="rect">
+            <a:avLst/>
+          </a:prstGeom>
+          <a:solidFill>
+            <a:srgbClr val="09142E"/>
+          </a:solidFill>
+          <a:ln w="12700">
+            <a:solidFill>
+              <a:srgbClr val="58A6FF"/>
+            </a:solidFill>
+          </a:ln>
+        </p:spPr>
+        <p:style>
+          <a:lnRef idx="1">
+            <a:schemeClr val="accent1"/>
+          </a:lnRef>
+          <a:fillRef idx="3">
+            <a:schemeClr val="accent1"/>
+          </a:fillRef>
+          <a:effectRef idx="2">
+            <a:schemeClr val="accent1"/>
+          </a:effectRef>
+          <a:fontRef idx="minor">
+            <a:schemeClr val="lt1"/>
+          </a:fontRef>
+        </p:style>
+        <p:txBody>
+          <a:bodyPr rtlCol="0" anchor="ctr"/>
+          <a:lstStyle/>
+          <a:p>
+            <a:pPr algn="ctr"/>
+          </a:p>
+        </p:txBody>
+      </p:sp>
+      <p:sp>
+        <p:nvSpPr>
+          <p:cNvPr id="20" name="TextBox 19"/>
+          <p:cNvSpPr txBox="1"/>
+          <p:nvPr/>
+        </p:nvSpPr>
+        <p:spPr>
+          <a:xfrm>
+            <a:off x="182880" y="1280160"/>
+            <a:ext cx="1234440" cy="260603"/>
+          </a:xfrm>
+          <a:prstGeom prst="rect">
+            <a:avLst/>
+          </a:prstGeom>
+          <a:noFill/>
+        </p:spPr>
+        <p:txBody>
+          <a:bodyPr wrap="square">
+            <a:spAutoFit/>
+          </a:bodyPr>
+          <a:lstStyle/>
+          <a:p>
+            <a:pPr algn="ctr"/>
+            <a:r>
+              <a:rPr sz="700" b="1">
+                <a:solidFill>
+                  <a:srgbClr val="F0F6FC"/>
+                </a:solidFill>
+              </a:rPr>
+              <a:t>propietario</a:t>
+            </a:r>
+          </a:p>
+        </p:txBody>
+      </p:sp>
+      <p:sp>
+        <p:nvSpPr>
+          <p:cNvPr id="21" name="Rectangle 20"/>
+          <p:cNvSpPr/>
+          <p:nvPr/>
+        </p:nvSpPr>
+        <p:spPr>
+          <a:xfrm>
+            <a:off x="182880" y="2194560"/>
+            <a:ext cx="1024128" cy="260603"/>
+          </a:xfrm>
+          <a:prstGeom prst="rect">
+            <a:avLst/>
+          </a:prstGeom>
+          <a:solidFill>
+            <a:srgbClr val="09142E"/>
+          </a:solidFill>
+          <a:ln w="12700">
+            <a:solidFill>
+              <a:srgbClr val="58A6FF"/>
+            </a:solidFill>
+          </a:ln>
+        </p:spPr>
+        <p:style>
+          <a:lnRef idx="1">
+            <a:schemeClr val="accent1"/>
+          </a:lnRef>
+          <a:fillRef idx="3">
+            <a:schemeClr val="accent1"/>
+          </a:fillRef>
+          <a:effectRef idx="2">
+            <a:schemeClr val="accent1"/>
+          </a:effectRef>
+          <a:fontRef idx="minor">
+            <a:schemeClr val="lt1"/>
+          </a:fontRef>
+        </p:style>
+        <p:txBody>
+          <a:bodyPr rtlCol="0" anchor="ctr"/>
+          <a:lstStyle/>
+          <a:p>
+            <a:pPr algn="ctr"/>
+          </a:p>
+        </p:txBody>
+      </p:sp>
+      <p:sp>
+        <p:nvSpPr>
+          <p:cNvPr id="22" name="TextBox 21"/>
+          <p:cNvSpPr txBox="1"/>
+          <p:nvPr/>
+        </p:nvSpPr>
+        <p:spPr>
+          <a:xfrm>
+            <a:off x="182880" y="2194560"/>
+            <a:ext cx="1024128" cy="260603"/>
+          </a:xfrm>
+          <a:prstGeom prst="rect">
+            <a:avLst/>
+          </a:prstGeom>
+          <a:noFill/>
+        </p:spPr>
+        <p:txBody>
+          <a:bodyPr wrap="square">
+            <a:spAutoFit/>
+          </a:bodyPr>
+          <a:lstStyle/>
+          <a:p>
+            <a:pPr algn="ctr"/>
+            <a:r>
+              <a:rPr sz="700" b="1">
+                <a:solidFill>
+                  <a:srgbClr val="F0F6FC"/>
+                </a:solidFill>
+              </a:rPr>
+              <a:t>establo</a:t>
+            </a:r>
+          </a:p>
+        </p:txBody>
+      </p:sp>
+      <p:sp>
+        <p:nvSpPr>
+          <p:cNvPr id="23" name="Rectangle 22"/>
+          <p:cNvSpPr/>
+          <p:nvPr/>
+        </p:nvSpPr>
+        <p:spPr>
+          <a:xfrm>
+            <a:off x="2057400" y="1737360"/>
+            <a:ext cx="1143000" cy="260603"/>
+          </a:xfrm>
+          <a:prstGeom prst="rect">
+            <a:avLst/>
+          </a:prstGeom>
+          <a:solidFill>
+            <a:srgbClr val="09142E"/>
+          </a:solidFill>
+          <a:ln w="12700">
+            <a:solidFill>
+              <a:srgbClr val="58A6FF"/>
+            </a:solidFill>
+          </a:ln>
+        </p:spPr>
+        <p:style>
+          <a:lnRef idx="1">
+            <a:schemeClr val="accent1"/>
+          </a:lnRef>
+          <a:fillRef idx="3">
+            <a:schemeClr val="accent1"/>
+          </a:fillRef>
+          <a:effectRef idx="2">
+            <a:schemeClr val="accent1"/>
+          </a:effectRef>
+          <a:fontRef idx="minor">
+            <a:schemeClr val="lt1"/>
+          </a:fontRef>
+        </p:style>
+        <p:txBody>
+          <a:bodyPr rtlCol="0" anchor="ctr"/>
+          <a:lstStyle/>
+          <a:p>
+            <a:pPr algn="ctr"/>
+          </a:p>
+        </p:txBody>
+      </p:sp>
+      <p:sp>
+        <p:nvSpPr>
+          <p:cNvPr id="24" name="TextBox 23"/>
+          <p:cNvSpPr txBox="1"/>
+          <p:nvPr/>
+        </p:nvSpPr>
+        <p:spPr>
+          <a:xfrm>
+            <a:off x="2057400" y="1737360"/>
+            <a:ext cx="1143000" cy="260603"/>
+          </a:xfrm>
+          <a:prstGeom prst="rect">
+            <a:avLst/>
+          </a:prstGeom>
+          <a:noFill/>
+        </p:spPr>
+        <p:txBody>
+          <a:bodyPr wrap="square">
+            <a:spAutoFit/>
+          </a:bodyPr>
+          <a:lstStyle/>
+          <a:p>
+            <a:pPr algn="ctr"/>
+            <a:r>
+              <a:rPr sz="700" b="1">
+                <a:solidFill>
+                  <a:srgbClr val="F0F6FC"/>
+                </a:solidFill>
+              </a:rPr>
+              <a:t>caballo</a:t>
+            </a:r>
+          </a:p>
+        </p:txBody>
+      </p:sp>
+      <p:sp>
+        <p:nvSpPr>
+          <p:cNvPr id="25" name="Rectangle 24"/>
+          <p:cNvSpPr/>
+          <p:nvPr/>
+        </p:nvSpPr>
+        <p:spPr>
+          <a:xfrm>
+            <a:off x="4389120" y="1280160"/>
+            <a:ext cx="960120" cy="260603"/>
+          </a:xfrm>
+          <a:prstGeom prst="rect">
+            <a:avLst/>
+          </a:prstGeom>
+          <a:solidFill>
+            <a:srgbClr val="09142E"/>
+          </a:solidFill>
+          <a:ln w="12700">
+            <a:solidFill>
+              <a:srgbClr val="58A6FF"/>
+            </a:solidFill>
+          </a:ln>
+        </p:spPr>
+        <p:style>
+          <a:lnRef idx="1">
+            <a:schemeClr val="accent1"/>
+          </a:lnRef>
+          <a:fillRef idx="3">
+            <a:schemeClr val="accent1"/>
+          </a:fillRef>
+          <a:effectRef idx="2">
+            <a:schemeClr val="accent1"/>
+          </a:effectRef>
+          <a:fontRef idx="minor">
+            <a:schemeClr val="lt1"/>
+          </a:fontRef>
+        </p:style>
+        <p:txBody>
+          <a:bodyPr rtlCol="0" anchor="ctr"/>
+          <a:lstStyle/>
+          <a:p>
+            <a:pPr algn="ctr"/>
+          </a:p>
+        </p:txBody>
+      </p:sp>
+      <p:sp>
+        <p:nvSpPr>
+          <p:cNvPr id="26" name="TextBox 25"/>
+          <p:cNvSpPr txBox="1"/>
+          <p:nvPr/>
+        </p:nvSpPr>
+        <p:spPr>
+          <a:xfrm>
+            <a:off x="4389120" y="1280160"/>
+            <a:ext cx="960120" cy="260603"/>
+          </a:xfrm>
+          <a:prstGeom prst="rect">
+            <a:avLst/>
+          </a:prstGeom>
+          <a:noFill/>
+        </p:spPr>
+        <p:txBody>
+          <a:bodyPr wrap="square">
+            <a:spAutoFit/>
+          </a:bodyPr>
+          <a:lstStyle/>
+          <a:p>
+            <a:pPr algn="ctr"/>
+            <a:r>
+              <a:rPr sz="700" b="1">
+                <a:solidFill>
+                  <a:srgbClr val="F0F6FC"/>
+                </a:solidFill>
+              </a:rPr>
+              <a:t>evento</a:t>
+            </a:r>
+          </a:p>
+        </p:txBody>
+      </p:sp>
+      <p:sp>
+        <p:nvSpPr>
+          <p:cNvPr id="27" name="Rectangle 26"/>
+          <p:cNvSpPr/>
+          <p:nvPr/>
+        </p:nvSpPr>
+        <p:spPr>
+          <a:xfrm>
+            <a:off x="4389120" y="2194560"/>
+            <a:ext cx="1170432" cy="260603"/>
+          </a:xfrm>
+          <a:prstGeom prst="rect">
+            <a:avLst/>
+          </a:prstGeom>
+          <a:solidFill>
+            <a:srgbClr val="09142E"/>
+          </a:solidFill>
+          <a:ln w="12700">
+            <a:solidFill>
+              <a:srgbClr val="58A6FF"/>
+            </a:solidFill>
+          </a:ln>
+        </p:spPr>
+        <p:style>
+          <a:lnRef idx="1">
+            <a:schemeClr val="accent1"/>
+          </a:lnRef>
+          <a:fillRef idx="3">
+            <a:schemeClr val="accent1"/>
+          </a:fillRef>
+          <a:effectRef idx="2">
+            <a:schemeClr val="accent1"/>
+          </a:effectRef>
+          <a:fontRef idx="minor">
+            <a:schemeClr val="lt1"/>
+          </a:fontRef>
+        </p:style>
+        <p:txBody>
+          <a:bodyPr rtlCol="0" anchor="ctr"/>
+          <a:lstStyle/>
+          <a:p>
+            <a:pPr algn="ctr"/>
+          </a:p>
+        </p:txBody>
+      </p:sp>
+      <p:sp>
+        <p:nvSpPr>
+          <p:cNvPr id="28" name="TextBox 27"/>
+          <p:cNvSpPr txBox="1"/>
+          <p:nvPr/>
+        </p:nvSpPr>
+        <p:spPr>
+          <a:xfrm>
+            <a:off x="4389120" y="2194560"/>
+            <a:ext cx="1170432" cy="260603"/>
+          </a:xfrm>
+          <a:prstGeom prst="rect">
+            <a:avLst/>
+          </a:prstGeom>
+          <a:noFill/>
+        </p:spPr>
+        <p:txBody>
+          <a:bodyPr wrap="square">
+            <a:spAutoFit/>
+          </a:bodyPr>
+          <a:lstStyle/>
+          <a:p>
+            <a:pPr algn="ctr"/>
+            <a:r>
+              <a:rPr sz="700" b="1">
+                <a:solidFill>
+                  <a:srgbClr val="F0F6FC"/>
+                </a:solidFill>
+              </a:rPr>
+              <a:t>inscripcion</a:t>
+            </a:r>
+          </a:p>
+        </p:txBody>
+      </p:sp>
+      <p:sp>
+        <p:nvSpPr>
+          <p:cNvPr id="29" name="Rectangle 28"/>
+          <p:cNvSpPr/>
+          <p:nvPr/>
+        </p:nvSpPr>
+        <p:spPr>
+          <a:xfrm>
+            <a:off x="1956816" y="2880360"/>
+            <a:ext cx="2212848" cy="260603"/>
+          </a:xfrm>
+          <a:prstGeom prst="rect">
+            <a:avLst/>
+          </a:prstGeom>
+          <a:solidFill>
+            <a:srgbClr val="09142E"/>
+          </a:solidFill>
+          <a:ln w="12700">
+            <a:solidFill>
+              <a:srgbClr val="58A6FF"/>
+            </a:solidFill>
+          </a:ln>
+        </p:spPr>
+        <p:style>
+          <a:lnRef idx="1">
+            <a:schemeClr val="accent1"/>
+          </a:lnRef>
+          <a:fillRef idx="3">
+            <a:schemeClr val="accent1"/>
+          </a:fillRef>
+          <a:effectRef idx="2">
+            <a:schemeClr val="accent1"/>
+          </a:effectRef>
+          <a:fontRef idx="minor">
+            <a:schemeClr val="lt1"/>
+          </a:fontRef>
+        </p:style>
+        <p:txBody>
+          <a:bodyPr rtlCol="0" anchor="ctr"/>
+          <a:lstStyle/>
+          <a:p>
+            <a:pPr algn="ctr"/>
+          </a:p>
+        </p:txBody>
+      </p:sp>
+      <p:sp>
+        <p:nvSpPr>
+          <p:cNvPr id="30" name="TextBox 29"/>
+          <p:cNvSpPr txBox="1"/>
+          <p:nvPr/>
+        </p:nvSpPr>
+        <p:spPr>
+          <a:xfrm>
+            <a:off x="1956816" y="2880360"/>
+            <a:ext cx="2212848" cy="260603"/>
+          </a:xfrm>
+          <a:prstGeom prst="rect">
+            <a:avLst/>
+          </a:prstGeom>
+          <a:noFill/>
+        </p:spPr>
+        <p:txBody>
+          <a:bodyPr wrap="square">
+            <a:spAutoFit/>
+          </a:bodyPr>
+          <a:lstStyle/>
+          <a:p>
+            <a:pPr algn="ctr"/>
+            <a:r>
+              <a:rPr sz="700" b="1">
+                <a:solidFill>
+                  <a:srgbClr val="F0F6FC"/>
+                </a:solidFill>
+              </a:rPr>
+              <a:t>historial_veterinario</a:t>
+            </a:r>
+          </a:p>
+        </p:txBody>
+      </p:sp>
+      <p:sp>
+        <p:nvSpPr>
+          <p:cNvPr id="31" name="Rectangle 30"/>
+          <p:cNvSpPr/>
+          <p:nvPr/>
+        </p:nvSpPr>
+        <p:spPr>
+          <a:xfrm>
+            <a:off x="4389120" y="2880360"/>
+            <a:ext cx="960120" cy="260603"/>
+          </a:xfrm>
+          <a:prstGeom prst="rect">
+            <a:avLst/>
+          </a:prstGeom>
+          <a:solidFill>
+            <a:srgbClr val="09142E"/>
+          </a:solidFill>
+          <a:ln w="12700">
+            <a:solidFill>
+              <a:srgbClr val="58A6FF"/>
+            </a:solidFill>
+          </a:ln>
+        </p:spPr>
+        <p:style>
+          <a:lnRef idx="1">
+            <a:schemeClr val="accent1"/>
+          </a:lnRef>
+          <a:fillRef idx="3">
+            <a:schemeClr val="accent1"/>
+          </a:fillRef>
+          <a:effectRef idx="2">
+            <a:schemeClr val="accent1"/>
+          </a:effectRef>
+          <a:fontRef idx="minor">
+            <a:schemeClr val="lt1"/>
+          </a:fontRef>
+        </p:style>
+        <p:txBody>
+          <a:bodyPr rtlCol="0" anchor="ctr"/>
+          <a:lstStyle/>
+          <a:p>
+            <a:pPr algn="ctr"/>
+          </a:p>
+        </p:txBody>
+      </p:sp>
+      <p:sp>
+        <p:nvSpPr>
+          <p:cNvPr id="32" name="TextBox 31"/>
+          <p:cNvSpPr txBox="1"/>
+          <p:nvPr/>
+        </p:nvSpPr>
+        <p:spPr>
+          <a:xfrm>
+            <a:off x="4389120" y="2880360"/>
+            <a:ext cx="960120" cy="260603"/>
+          </a:xfrm>
+          <a:prstGeom prst="rect">
+            <a:avLst/>
+          </a:prstGeom>
+          <a:noFill/>
+        </p:spPr>
+        <p:txBody>
+          <a:bodyPr wrap="square">
+            <a:spAutoFit/>
+          </a:bodyPr>
+          <a:lstStyle/>
+          <a:p>
+            <a:pPr algn="ctr"/>
+            <a:r>
+              <a:rPr sz="700" b="1">
+                <a:solidFill>
+                  <a:srgbClr val="F0F6FC"/>
+                </a:solidFill>
+              </a:rPr>
+              <a:t>factura</a:t>
+            </a:r>
+          </a:p>
+        </p:txBody>
+      </p:sp>
+      <p:cxnSp>
+        <p:nvCxnSpPr>
+          <p:cNvPr id="33" name="Connector 32"/>
+          <p:cNvCxnSpPr/>
+          <p:nvPr/>
+        </p:nvCxnSpPr>
+        <p:spPr>
+          <a:xfrm>
+            <a:off x="1417320" y="1410004"/>
+            <a:ext cx="640080" cy="457200"/>
+          </a:xfrm>
+          <a:prstGeom prst="line">
+            <a:avLst/>
+          </a:prstGeom>
+          <a:ln w="10160">
+            <a:solidFill>
+              <a:srgbClr val="58A6FF"/>
+            </a:solidFill>
+          </a:ln>
+        </p:spPr>
+        <p:style>
+          <a:lnRef idx="2">
+            <a:schemeClr val="accent1"/>
+          </a:lnRef>
+          <a:fillRef idx="0">
+            <a:schemeClr val="accent1"/>
+          </a:fillRef>
+          <a:effectRef idx="1">
+            <a:schemeClr val="accent1"/>
+          </a:effectRef>
+          <a:fontRef idx="minor">
+            <a:schemeClr val="tx1"/>
+          </a:fontRef>
+        </p:style>
+      </p:cxnSp>
+      <p:cxnSp>
+        <p:nvCxnSpPr>
+          <p:cNvPr id="34" name="Connector 33"/>
+          <p:cNvCxnSpPr/>
+          <p:nvPr/>
+        </p:nvCxnSpPr>
+        <p:spPr>
+          <a:xfrm flipV="1">
+            <a:off x="1207008" y="1997964"/>
+            <a:ext cx="850392" cy="326440"/>
+          </a:xfrm>
+          <a:prstGeom prst="line">
+            <a:avLst/>
+          </a:prstGeom>
+          <a:ln w="10160">
+            <a:solidFill>
+              <a:srgbClr val="58A6FF"/>
+            </a:solidFill>
+          </a:ln>
+        </p:spPr>
+        <p:style>
+          <a:lnRef idx="2">
+            <a:schemeClr val="accent1"/>
+          </a:lnRef>
+          <a:fillRef idx="0">
+            <a:schemeClr val="accent1"/>
+          </a:fillRef>
+          <a:effectRef idx="1">
+            <a:schemeClr val="accent1"/>
+          </a:effectRef>
+          <a:fontRef idx="minor">
+            <a:schemeClr val="tx1"/>
+          </a:fontRef>
+        </p:style>
+      </p:cxnSp>
+      <p:cxnSp>
+        <p:nvCxnSpPr>
+          <p:cNvPr id="35" name="Connector 34"/>
+          <p:cNvCxnSpPr/>
+          <p:nvPr/>
+        </p:nvCxnSpPr>
+        <p:spPr>
+          <a:xfrm>
+            <a:off x="2628900" y="1997964"/>
+            <a:ext cx="0" cy="882396"/>
+          </a:xfrm>
+          <a:prstGeom prst="line">
+            <a:avLst/>
+          </a:prstGeom>
+          <a:ln w="10160">
+            <a:solidFill>
+              <a:srgbClr val="58A6FF"/>
+            </a:solidFill>
+          </a:ln>
+        </p:spPr>
+        <p:style>
+          <a:lnRef idx="2">
+            <a:schemeClr val="accent1"/>
+          </a:lnRef>
+          <a:fillRef idx="0">
+            <a:schemeClr val="accent1"/>
+          </a:fillRef>
+          <a:effectRef idx="1">
+            <a:schemeClr val="accent1"/>
+          </a:effectRef>
+          <a:fontRef idx="minor">
+            <a:schemeClr val="tx1"/>
+          </a:fontRef>
+        </p:style>
+      </p:cxnSp>
+      <p:cxnSp>
+        <p:nvCxnSpPr>
+          <p:cNvPr id="36" name="Connector 35"/>
+          <p:cNvCxnSpPr/>
+          <p:nvPr/>
+        </p:nvCxnSpPr>
+        <p:spPr>
+          <a:xfrm>
+            <a:off x="3200400" y="1867204"/>
+            <a:ext cx="1188720" cy="457200"/>
+          </a:xfrm>
+          <a:prstGeom prst="line">
+            <a:avLst/>
+          </a:prstGeom>
+          <a:ln w="10160">
+            <a:solidFill>
+              <a:srgbClr val="58A6FF"/>
+            </a:solidFill>
+          </a:ln>
+        </p:spPr>
+        <p:style>
+          <a:lnRef idx="2">
+            <a:schemeClr val="accent1"/>
+          </a:lnRef>
+          <a:fillRef idx="0">
+            <a:schemeClr val="accent1"/>
+          </a:fillRef>
+          <a:effectRef idx="1">
+            <a:schemeClr val="accent1"/>
+          </a:effectRef>
+          <a:fontRef idx="minor">
+            <a:schemeClr val="tx1"/>
+          </a:fontRef>
+        </p:style>
+      </p:cxnSp>
+      <p:cxnSp>
+        <p:nvCxnSpPr>
+          <p:cNvPr id="37" name="Connector 36"/>
+          <p:cNvCxnSpPr/>
+          <p:nvPr/>
+        </p:nvCxnSpPr>
+        <p:spPr>
+          <a:xfrm>
+            <a:off x="4869180" y="1540764"/>
+            <a:ext cx="0" cy="653796"/>
+          </a:xfrm>
+          <a:prstGeom prst="line">
+            <a:avLst/>
+          </a:prstGeom>
+          <a:ln w="10160">
+            <a:solidFill>
+              <a:srgbClr val="58A6FF"/>
+            </a:solidFill>
+          </a:ln>
+        </p:spPr>
+        <p:style>
+          <a:lnRef idx="2">
+            <a:schemeClr val="accent1"/>
+          </a:lnRef>
+          <a:fillRef idx="0">
+            <a:schemeClr val="accent1"/>
+          </a:fillRef>
+          <a:effectRef idx="1">
+            <a:schemeClr val="accent1"/>
+          </a:effectRef>
+          <a:fontRef idx="minor">
+            <a:schemeClr val="tx1"/>
+          </a:fontRef>
+        </p:style>
+      </p:cxnSp>
+      <p:cxnSp>
+        <p:nvCxnSpPr>
+          <p:cNvPr id="38" name="Connector 37"/>
+          <p:cNvCxnSpPr/>
+          <p:nvPr/>
+        </p:nvCxnSpPr>
+        <p:spPr>
+          <a:xfrm>
+            <a:off x="1417320" y="1410004"/>
+            <a:ext cx="2971800" cy="1600200"/>
+          </a:xfrm>
+          <a:prstGeom prst="line">
+            <a:avLst/>
+          </a:prstGeom>
+          <a:ln w="10160">
+            <a:solidFill>
+              <a:srgbClr val="58A6FF"/>
+            </a:solidFill>
+          </a:ln>
+        </p:spPr>
+        <p:style>
+          <a:lnRef idx="2">
+            <a:schemeClr val="accent1"/>
+          </a:lnRef>
+          <a:fillRef idx="0">
+            <a:schemeClr val="accent1"/>
+          </a:fillRef>
+          <a:effectRef idx="1">
+            <a:schemeClr val="accent1"/>
+          </a:effectRef>
+          <a:fontRef idx="minor">
+            <a:schemeClr val="tx1"/>
+          </a:fontRef>
+        </p:style>
+      </p:cxnSp>
+      <p:sp>
+        <p:nvSpPr>
+          <p:cNvPr id="39" name="Rectangle 38"/>
+          <p:cNvSpPr/>
+          <p:nvPr/>
+        </p:nvSpPr>
+        <p:spPr>
+          <a:xfrm>
+            <a:off x="182880" y="3977639"/>
+            <a:ext cx="1143000" cy="260603"/>
+          </a:xfrm>
+          <a:prstGeom prst="rect">
+            <a:avLst/>
+          </a:prstGeom>
+          <a:solidFill>
+            <a:srgbClr val="18092E"/>
+          </a:solidFill>
+          <a:ln w="12700">
+            <a:solidFill>
+              <a:srgbClr val="BC8CFF"/>
+            </a:solidFill>
+          </a:ln>
+        </p:spPr>
+        <p:style>
+          <a:lnRef idx="1">
+            <a:schemeClr val="accent1"/>
+          </a:lnRef>
+          <a:fillRef idx="3">
+            <a:schemeClr val="accent1"/>
+          </a:fillRef>
+          <a:effectRef idx="2">
+            <a:schemeClr val="accent1"/>
+          </a:effectRef>
+          <a:fontRef idx="minor">
+            <a:schemeClr val="lt1"/>
+          </a:fontRef>
+        </p:style>
+        <p:txBody>
+          <a:bodyPr rtlCol="0" anchor="ctr"/>
+          <a:lstStyle/>
+          <a:p>
+            <a:pPr algn="ctr"/>
+          </a:p>
+        </p:txBody>
+      </p:sp>
+      <p:sp>
+        <p:nvSpPr>
+          <p:cNvPr id="40" name="TextBox 39"/>
+          <p:cNvSpPr txBox="1"/>
+          <p:nvPr/>
+        </p:nvSpPr>
+        <p:spPr>
+          <a:xfrm>
+            <a:off x="182880" y="3977639"/>
+            <a:ext cx="1143000" cy="260603"/>
+          </a:xfrm>
+          <a:prstGeom prst="rect">
+            <a:avLst/>
+          </a:prstGeom>
+          <a:noFill/>
+        </p:spPr>
+        <p:txBody>
+          <a:bodyPr wrap="square">
+            <a:spAutoFit/>
+          </a:bodyPr>
+          <a:lstStyle/>
+          <a:p>
+            <a:pPr algn="ctr"/>
+            <a:r>
+              <a:rPr sz="700" b="1">
+                <a:solidFill>
+                  <a:srgbClr val="F0F6FC"/>
+                </a:solidFill>
+              </a:rPr>
+              <a:t>suministro</a:t>
+            </a:r>
+          </a:p>
+        </p:txBody>
+      </p:sp>
+      <p:sp>
+        <p:nvSpPr>
+          <p:cNvPr id="41" name="Rectangle 40"/>
+          <p:cNvSpPr/>
+          <p:nvPr/>
+        </p:nvSpPr>
+        <p:spPr>
+          <a:xfrm>
+            <a:off x="1956816" y="3977639"/>
+            <a:ext cx="1298448" cy="260603"/>
+          </a:xfrm>
+          <a:prstGeom prst="rect">
+            <a:avLst/>
+          </a:prstGeom>
+          <a:solidFill>
+            <a:srgbClr val="18092E"/>
+          </a:solidFill>
+          <a:ln w="12700">
+            <a:solidFill>
+              <a:srgbClr val="BC8CFF"/>
+            </a:solidFill>
+          </a:ln>
+        </p:spPr>
+        <p:style>
+          <a:lnRef idx="1">
+            <a:schemeClr val="accent1"/>
+          </a:lnRef>
+          <a:fillRef idx="3">
+            <a:schemeClr val="accent1"/>
+          </a:fillRef>
+          <a:effectRef idx="2">
+            <a:schemeClr val="accent1"/>
+          </a:effectRef>
+          <a:fontRef idx="minor">
+            <a:schemeClr val="lt1"/>
+          </a:fontRef>
+        </p:style>
+        <p:txBody>
+          <a:bodyPr rtlCol="0" anchor="ctr"/>
+          <a:lstStyle/>
+          <a:p>
+            <a:pPr algn="ctr"/>
+          </a:p>
+        </p:txBody>
+      </p:sp>
+      <p:sp>
+        <p:nvSpPr>
+          <p:cNvPr id="42" name="TextBox 41"/>
+          <p:cNvSpPr txBox="1"/>
+          <p:nvPr/>
+        </p:nvSpPr>
+        <p:spPr>
+          <a:xfrm>
+            <a:off x="1956816" y="3977639"/>
+            <a:ext cx="1298448" cy="260603"/>
+          </a:xfrm>
+          <a:prstGeom prst="rect">
+            <a:avLst/>
+          </a:prstGeom>
+          <a:noFill/>
+        </p:spPr>
+        <p:txBody>
+          <a:bodyPr wrap="square">
+            <a:spAutoFit/>
+          </a:bodyPr>
+          <a:lstStyle/>
+          <a:p>
+            <a:pPr algn="ctr"/>
+            <a:r>
+              <a:rPr sz="700" b="1">
+                <a:solidFill>
+                  <a:srgbClr val="F0F6FC"/>
+                </a:solidFill>
+              </a:rPr>
+              <a:t>alimentacion</a:t>
+            </a:r>
+          </a:p>
+        </p:txBody>
+      </p:sp>
+      <p:sp>
+        <p:nvSpPr>
+          <p:cNvPr id="43" name="Rectangle 42"/>
+          <p:cNvSpPr/>
+          <p:nvPr/>
+        </p:nvSpPr>
+        <p:spPr>
+          <a:xfrm>
+            <a:off x="4251960" y="3977639"/>
+            <a:ext cx="1874519" cy="260603"/>
+          </a:xfrm>
+          <a:prstGeom prst="rect">
+            <a:avLst/>
+          </a:prstGeom>
+          <a:solidFill>
+            <a:srgbClr val="18092E"/>
+          </a:solidFill>
+          <a:ln w="12700">
+            <a:solidFill>
+              <a:srgbClr val="BC8CFF"/>
+            </a:solidFill>
+          </a:ln>
+        </p:spPr>
+        <p:style>
+          <a:lnRef idx="1">
+            <a:schemeClr val="accent1"/>
+          </a:lnRef>
+          <a:fillRef idx="3">
+            <a:schemeClr val="accent1"/>
+          </a:fillRef>
+          <a:effectRef idx="2">
+            <a:schemeClr val="accent1"/>
+          </a:effectRef>
+          <a:fontRef idx="minor">
+            <a:schemeClr val="lt1"/>
+          </a:fontRef>
+        </p:style>
+        <p:txBody>
+          <a:bodyPr rtlCol="0" anchor="ctr"/>
+          <a:lstStyle/>
+          <a:p>
+            <a:pPr algn="ctr"/>
+          </a:p>
+        </p:txBody>
+      </p:sp>
+      <p:sp>
+        <p:nvSpPr>
+          <p:cNvPr id="44" name="TextBox 43"/>
+          <p:cNvSpPr txBox="1"/>
+          <p:nvPr/>
+        </p:nvSpPr>
+        <p:spPr>
+          <a:xfrm>
+            <a:off x="4251960" y="3977639"/>
+            <a:ext cx="1874519" cy="260603"/>
+          </a:xfrm>
+          <a:prstGeom prst="rect">
+            <a:avLst/>
+          </a:prstGeom>
+          <a:noFill/>
+        </p:spPr>
+        <p:txBody>
+          <a:bodyPr wrap="square">
+            <a:spAutoFit/>
+          </a:bodyPr>
+          <a:lstStyle/>
+          <a:p>
+            <a:pPr algn="ctr"/>
+            <a:r>
+              <a:rPr sz="700" b="1">
+                <a:solidFill>
+                  <a:srgbClr val="F0F6FC"/>
+                </a:solidFill>
+              </a:rPr>
+              <a:t>resultado_carrera</a:t>
+            </a:r>
+          </a:p>
+        </p:txBody>
+      </p:sp>
+      <p:sp>
+        <p:nvSpPr>
+          <p:cNvPr id="45" name="Rectangle 44"/>
+          <p:cNvSpPr/>
+          <p:nvPr/>
+        </p:nvSpPr>
+        <p:spPr>
+          <a:xfrm>
+            <a:off x="6629400" y="2194560"/>
+            <a:ext cx="1993392" cy="260603"/>
+          </a:xfrm>
+          <a:prstGeom prst="rect">
+            <a:avLst/>
+          </a:prstGeom>
+          <a:solidFill>
+            <a:srgbClr val="18092E"/>
+          </a:solidFill>
+          <a:ln w="12700">
+            <a:solidFill>
+              <a:srgbClr val="BC8CFF"/>
+            </a:solidFill>
+          </a:ln>
+        </p:spPr>
+        <p:style>
+          <a:lnRef idx="1">
+            <a:schemeClr val="accent1"/>
+          </a:lnRef>
+          <a:fillRef idx="3">
+            <a:schemeClr val="accent1"/>
+          </a:fillRef>
+          <a:effectRef idx="2">
+            <a:schemeClr val="accent1"/>
+          </a:effectRef>
+          <a:fontRef idx="minor">
+            <a:schemeClr val="lt1"/>
+          </a:fontRef>
+        </p:style>
+        <p:txBody>
+          <a:bodyPr rtlCol="0" anchor="ctr"/>
+          <a:lstStyle/>
+          <a:p>
+            <a:pPr algn="ctr"/>
+          </a:p>
+        </p:txBody>
+      </p:sp>
+      <p:sp>
+        <p:nvSpPr>
+          <p:cNvPr id="46" name="TextBox 45"/>
+          <p:cNvSpPr txBox="1"/>
+          <p:nvPr/>
+        </p:nvSpPr>
+        <p:spPr>
+          <a:xfrm>
+            <a:off x="6629400" y="2194560"/>
+            <a:ext cx="1993392" cy="260603"/>
+          </a:xfrm>
+          <a:prstGeom prst="rect">
+            <a:avLst/>
+          </a:prstGeom>
+          <a:noFill/>
+        </p:spPr>
+        <p:txBody>
+          <a:bodyPr wrap="square">
+            <a:spAutoFit/>
+          </a:bodyPr>
+          <a:lstStyle/>
+          <a:p>
+            <a:pPr algn="ctr"/>
+            <a:r>
+              <a:rPr sz="700" b="1">
+                <a:solidFill>
+                  <a:srgbClr val="F0F6FC"/>
+                </a:solidFill>
+              </a:rPr>
+              <a:t>alerta_veterinaria</a:t>
+            </a:r>
+          </a:p>
+        </p:txBody>
+      </p:sp>
+      <p:sp>
+        <p:nvSpPr>
+          <p:cNvPr id="47" name="Rectangle 46"/>
+          <p:cNvSpPr/>
+          <p:nvPr/>
+        </p:nvSpPr>
+        <p:spPr>
+          <a:xfrm>
+            <a:off x="6629400" y="3108960"/>
+            <a:ext cx="2176272" cy="260603"/>
+          </a:xfrm>
+          <a:prstGeom prst="rect">
+            <a:avLst/>
+          </a:prstGeom>
+          <a:solidFill>
+            <a:srgbClr val="18092E"/>
+          </a:solidFill>
+          <a:ln w="12700">
+            <a:solidFill>
+              <a:srgbClr val="BC8CFF"/>
+            </a:solidFill>
+          </a:ln>
+        </p:spPr>
+        <p:style>
+          <a:lnRef idx="1">
+            <a:schemeClr val="accent1"/>
+          </a:lnRef>
+          <a:fillRef idx="3">
+            <a:schemeClr val="accent1"/>
+          </a:fillRef>
+          <a:effectRef idx="2">
+            <a:schemeClr val="accent1"/>
+          </a:effectRef>
+          <a:fontRef idx="minor">
+            <a:schemeClr val="lt1"/>
+          </a:fontRef>
+        </p:style>
+        <p:txBody>
+          <a:bodyPr rtlCol="0" anchor="ctr"/>
+          <a:lstStyle/>
+          <a:p>
+            <a:pPr algn="ctr"/>
+          </a:p>
+        </p:txBody>
+      </p:sp>
+      <p:sp>
+        <p:nvSpPr>
+          <p:cNvPr id="48" name="TextBox 47"/>
+          <p:cNvSpPr txBox="1"/>
+          <p:nvPr/>
+        </p:nvSpPr>
+        <p:spPr>
+          <a:xfrm>
+            <a:off x="6629400" y="3108960"/>
+            <a:ext cx="2176272" cy="260603"/>
+          </a:xfrm>
+          <a:prstGeom prst="rect">
+            <a:avLst/>
+          </a:prstGeom>
+          <a:noFill/>
+        </p:spPr>
+        <p:txBody>
+          <a:bodyPr wrap="square">
+            <a:spAutoFit/>
+          </a:bodyPr>
+          <a:lstStyle/>
+          <a:p>
+            <a:pPr algn="ctr"/>
+            <a:r>
+              <a:rPr sz="700" b="1">
+                <a:solidFill>
+                  <a:srgbClr val="F0F6FC"/>
+                </a:solidFill>
+              </a:rPr>
+              <a:t>historial_transaccion</a:t>
+            </a:r>
+          </a:p>
+        </p:txBody>
+      </p:sp>
+      <p:cxnSp>
+        <p:nvCxnSpPr>
+          <p:cNvPr id="49" name="Connector 48"/>
+          <p:cNvCxnSpPr/>
+          <p:nvPr/>
+        </p:nvCxnSpPr>
+        <p:spPr>
+          <a:xfrm>
+            <a:off x="1325880" y="4107484"/>
+            <a:ext cx="630936" cy="0"/>
+          </a:xfrm>
+          <a:prstGeom prst="line">
+            <a:avLst/>
+          </a:prstGeom>
+          <a:ln w="10160">
+            <a:solidFill>
+              <a:srgbClr val="BC8CFF"/>
+            </a:solidFill>
+          </a:ln>
+        </p:spPr>
+        <p:style>
+          <a:lnRef idx="2">
+            <a:schemeClr val="accent1"/>
+          </a:lnRef>
+          <a:fillRef idx="0">
+            <a:schemeClr val="accent1"/>
+          </a:fillRef>
+          <a:effectRef idx="1">
+            <a:schemeClr val="accent1"/>
+          </a:effectRef>
+          <a:fontRef idx="minor">
+            <a:schemeClr val="tx1"/>
+          </a:fontRef>
+        </p:style>
+      </p:cxnSp>
+      <p:cxnSp>
+        <p:nvCxnSpPr>
+          <p:cNvPr id="50" name="Connector 49"/>
+          <p:cNvCxnSpPr/>
+          <p:nvPr/>
+        </p:nvCxnSpPr>
+        <p:spPr>
+          <a:xfrm>
+            <a:off x="2103120" y="1997964"/>
+            <a:ext cx="0" cy="1979675"/>
+          </a:xfrm>
+          <a:prstGeom prst="line">
+            <a:avLst/>
+          </a:prstGeom>
+          <a:ln w="10160">
+            <a:solidFill>
+              <a:srgbClr val="BC8CFF"/>
+            </a:solidFill>
+          </a:ln>
+        </p:spPr>
+        <p:style>
+          <a:lnRef idx="2">
+            <a:schemeClr val="accent1"/>
+          </a:lnRef>
+          <a:fillRef idx="0">
+            <a:schemeClr val="accent1"/>
+          </a:fillRef>
+          <a:effectRef idx="1">
+            <a:schemeClr val="accent1"/>
+          </a:effectRef>
+          <a:fontRef idx="minor">
+            <a:schemeClr val="tx1"/>
+          </a:fontRef>
+        </p:style>
+      </p:cxnSp>
+      <p:cxnSp>
+        <p:nvCxnSpPr>
+          <p:cNvPr id="51" name="Connector 50"/>
+          <p:cNvCxnSpPr/>
+          <p:nvPr/>
+        </p:nvCxnSpPr>
+        <p:spPr>
+          <a:xfrm>
+            <a:off x="4869180" y="1540764"/>
+            <a:ext cx="320040" cy="2436875"/>
+          </a:xfrm>
+          <a:prstGeom prst="line">
+            <a:avLst/>
+          </a:prstGeom>
+          <a:ln w="10160">
+            <a:solidFill>
+              <a:srgbClr val="BC8CFF"/>
+            </a:solidFill>
+          </a:ln>
+        </p:spPr>
+        <p:style>
+          <a:lnRef idx="2">
+            <a:schemeClr val="accent1"/>
+          </a:lnRef>
+          <a:fillRef idx="0">
+            <a:schemeClr val="accent1"/>
+          </a:fillRef>
+          <a:effectRef idx="1">
+            <a:schemeClr val="accent1"/>
+          </a:effectRef>
+          <a:fontRef idx="minor">
+            <a:schemeClr val="tx1"/>
+          </a:fontRef>
+        </p:style>
+      </p:cxnSp>
+      <p:cxnSp>
+        <p:nvCxnSpPr>
+          <p:cNvPr id="52" name="Connector 51"/>
+          <p:cNvCxnSpPr/>
+          <p:nvPr/>
+        </p:nvCxnSpPr>
+        <p:spPr>
+          <a:xfrm>
+            <a:off x="3200400" y="1867204"/>
+            <a:ext cx="3429000" cy="457200"/>
+          </a:xfrm>
+          <a:prstGeom prst="line">
+            <a:avLst/>
+          </a:prstGeom>
+          <a:ln w="10160">
+            <a:solidFill>
+              <a:srgbClr val="BC8CFF"/>
+            </a:solidFill>
+          </a:ln>
+        </p:spPr>
+        <p:style>
+          <a:lnRef idx="2">
+            <a:schemeClr val="accent1"/>
+          </a:lnRef>
+          <a:fillRef idx="0">
+            <a:schemeClr val="accent1"/>
+          </a:fillRef>
+          <a:effectRef idx="1">
+            <a:schemeClr val="accent1"/>
+          </a:effectRef>
+          <a:fontRef idx="minor">
+            <a:schemeClr val="tx1"/>
+          </a:fontRef>
+        </p:style>
+      </p:cxnSp>
+      <p:cxnSp>
+        <p:nvCxnSpPr>
+          <p:cNvPr id="53" name="Connector 52"/>
+          <p:cNvCxnSpPr/>
+          <p:nvPr/>
+        </p:nvCxnSpPr>
+        <p:spPr>
+          <a:xfrm>
+            <a:off x="5349240" y="3010204"/>
+            <a:ext cx="1280160" cy="228600"/>
+          </a:xfrm>
+          <a:prstGeom prst="line">
+            <a:avLst/>
+          </a:prstGeom>
+          <a:ln w="10160">
+            <a:solidFill>
+              <a:srgbClr val="BC8CFF"/>
+            </a:solidFill>
+          </a:ln>
+        </p:spPr>
+        <p:style>
+          <a:lnRef idx="2">
+            <a:schemeClr val="accent1"/>
+          </a:lnRef>
+          <a:fillRef idx="0">
+            <a:schemeClr val="accent1"/>
+          </a:fillRef>
+          <a:effectRef idx="1">
+            <a:schemeClr val="accent1"/>
+          </a:effectRef>
+          <a:fontRef idx="minor">
+            <a:schemeClr val="tx1"/>
+          </a:fontRef>
+        </p:style>
+      </p:cxnSp>
+      <p:sp>
+        <p:nvSpPr>
+          <p:cNvPr id="54" name="Rectangle 53"/>
+          <p:cNvSpPr/>
+          <p:nvPr/>
+        </p:nvSpPr>
+        <p:spPr>
+          <a:xfrm>
+            <a:off x="9052560" y="1280160"/>
+            <a:ext cx="1143000" cy="260603"/>
+          </a:xfrm>
+          <a:prstGeom prst="rect">
+            <a:avLst/>
+          </a:prstGeom>
+          <a:solidFill>
+            <a:srgbClr val="221205"/>
+          </a:solidFill>
+          <a:ln w="12700">
+            <a:solidFill>
+              <a:srgbClr val="FFA657"/>
+            </a:solidFill>
+          </a:ln>
+        </p:spPr>
+        <p:style>
+          <a:lnRef idx="1">
+            <a:schemeClr val="accent1"/>
+          </a:lnRef>
+          <a:fillRef idx="3">
+            <a:schemeClr val="accent1"/>
+          </a:fillRef>
+          <a:effectRef idx="2">
+            <a:schemeClr val="accent1"/>
+          </a:effectRef>
+          <a:fontRef idx="minor">
+            <a:schemeClr val="lt1"/>
+          </a:fontRef>
+        </p:style>
+        <p:txBody>
+          <a:bodyPr rtlCol="0" anchor="ctr"/>
+          <a:lstStyle/>
+          <a:p>
+            <a:pPr algn="ctr"/>
+          </a:p>
+        </p:txBody>
+      </p:sp>
+      <p:sp>
+        <p:nvSpPr>
+          <p:cNvPr id="55" name="TextBox 54"/>
+          <p:cNvSpPr txBox="1"/>
+          <p:nvPr/>
+        </p:nvSpPr>
+        <p:spPr>
+          <a:xfrm>
+            <a:off x="9052560" y="1280160"/>
+            <a:ext cx="1143000" cy="260603"/>
+          </a:xfrm>
+          <a:prstGeom prst="rect">
+            <a:avLst/>
+          </a:prstGeom>
+          <a:noFill/>
+        </p:spPr>
+        <p:txBody>
+          <a:bodyPr wrap="square">
+            <a:spAutoFit/>
+          </a:bodyPr>
+          <a:lstStyle/>
+          <a:p>
+            <a:pPr algn="ctr"/>
+            <a:r>
+              <a:rPr sz="700" b="1">
+                <a:solidFill>
+                  <a:srgbClr val="F0F6FC"/>
+                </a:solidFill>
+              </a:rPr>
+              <a:t>usuarios</a:t>
+            </a:r>
+          </a:p>
+        </p:txBody>
+      </p:sp>
+      <p:sp>
+        <p:nvSpPr>
+          <p:cNvPr id="56" name="Rectangle 55"/>
+          <p:cNvSpPr/>
+          <p:nvPr/>
+        </p:nvSpPr>
+        <p:spPr>
+          <a:xfrm>
+            <a:off x="9052560" y="2194560"/>
+            <a:ext cx="2011680" cy="260603"/>
+          </a:xfrm>
+          <a:prstGeom prst="rect">
+            <a:avLst/>
+          </a:prstGeom>
+          <a:solidFill>
+            <a:srgbClr val="221205"/>
+          </a:solidFill>
+          <a:ln w="12700">
+            <a:solidFill>
+              <a:srgbClr val="FFA657"/>
+            </a:solidFill>
+          </a:ln>
+        </p:spPr>
+        <p:style>
+          <a:lnRef idx="1">
+            <a:schemeClr val="accent1"/>
+          </a:lnRef>
+          <a:fillRef idx="3">
+            <a:schemeClr val="accent1"/>
+          </a:fillRef>
+          <a:effectRef idx="2">
+            <a:schemeClr val="accent1"/>
+          </a:effectRef>
+          <a:fontRef idx="minor">
+            <a:schemeClr val="lt1"/>
+          </a:fontRef>
+        </p:style>
+        <p:txBody>
+          <a:bodyPr rtlCol="0" anchor="ctr"/>
+          <a:lstStyle/>
+          <a:p>
+            <a:pPr algn="ctr"/>
+          </a:p>
+        </p:txBody>
+      </p:sp>
+      <p:sp>
+        <p:nvSpPr>
+          <p:cNvPr id="57" name="TextBox 56"/>
+          <p:cNvSpPr txBox="1"/>
+          <p:nvPr/>
+        </p:nvSpPr>
+        <p:spPr>
+          <a:xfrm>
+            <a:off x="9052560" y="2194560"/>
+            <a:ext cx="2011680" cy="260603"/>
+          </a:xfrm>
+          <a:prstGeom prst="rect">
+            <a:avLst/>
+          </a:prstGeom>
+          <a:noFill/>
+        </p:spPr>
+        <p:txBody>
+          <a:bodyPr wrap="square">
+            <a:spAutoFit/>
+          </a:bodyPr>
+          <a:lstStyle/>
+          <a:p>
+            <a:pPr algn="ctr"/>
+            <a:r>
+              <a:rPr sz="700" b="1">
+                <a:solidFill>
+                  <a:srgbClr val="F0F6FC"/>
+                </a:solidFill>
+              </a:rPr>
+              <a:t>bitacora_auditoria</a:t>
+            </a:r>
+          </a:p>
+        </p:txBody>
+      </p:sp>
+      <p:sp>
+        <p:nvSpPr>
+          <p:cNvPr id="58" name="Rectangle 57"/>
+          <p:cNvSpPr/>
+          <p:nvPr/>
+        </p:nvSpPr>
+        <p:spPr>
+          <a:xfrm>
+            <a:off x="9052560" y="3794760"/>
+            <a:ext cx="2999232" cy="2011680"/>
+          </a:xfrm>
+          <a:prstGeom prst="rect">
+            <a:avLst/>
+          </a:prstGeom>
+          <a:solidFill>
+            <a:srgbClr val="161B27"/>
+          </a:solidFill>
+          <a:ln w="12700">
+            <a:solidFill>
+              <a:srgbClr val="30363D"/>
+            </a:solidFill>
+          </a:ln>
+        </p:spPr>
+        <p:style>
+          <a:lnRef idx="1">
+            <a:schemeClr val="accent1"/>
+          </a:lnRef>
+          <a:fillRef idx="3">
+            <a:schemeClr val="accent1"/>
+          </a:fillRef>
+          <a:effectRef idx="2">
+            <a:schemeClr val="accent1"/>
+          </a:effectRef>
+          <a:fontRef idx="minor">
+            <a:schemeClr val="lt1"/>
+          </a:fontRef>
+        </p:style>
+        <p:txBody>
+          <a:bodyPr rtlCol="0" anchor="ctr"/>
+          <a:lstStyle/>
+          <a:p>
+            <a:pPr algn="ctr"/>
+          </a:p>
+        </p:txBody>
+      </p:sp>
+      <p:sp>
+        <p:nvSpPr>
+          <p:cNvPr id="59" name="TextBox 58"/>
+          <p:cNvSpPr txBox="1"/>
+          <p:nvPr/>
+        </p:nvSpPr>
+        <p:spPr>
+          <a:xfrm>
+            <a:off x="9052560" y="3849624"/>
+            <a:ext cx="2999232" cy="256032"/>
+          </a:xfrm>
+          <a:prstGeom prst="rect">
+            <a:avLst/>
+          </a:prstGeom>
+          <a:noFill/>
+        </p:spPr>
+        <p:txBody>
+          <a:bodyPr wrap="square">
+            <a:spAutoFit/>
+          </a:bodyPr>
+          <a:lstStyle/>
+          <a:p>
+            <a:pPr algn="ctr"/>
+            <a:r>
+              <a:rPr sz="850" b="1">
+                <a:solidFill>
+                  <a:srgbClr val="F0F6FC"/>
+                </a:solidFill>
+              </a:rPr>
+              <a:t>Leyenda</a:t>
+            </a:r>
+          </a:p>
+        </p:txBody>
+      </p:sp>
+      <p:sp>
+        <p:nvSpPr>
+          <p:cNvPr id="60" name="Rectangle 59"/>
+          <p:cNvSpPr/>
+          <p:nvPr/>
+        </p:nvSpPr>
+        <p:spPr>
+          <a:xfrm>
+            <a:off x="9180576" y="4197096"/>
+            <a:ext cx="201168" cy="182880"/>
+          </a:xfrm>
+          <a:prstGeom prst="rect">
+            <a:avLst/>
+          </a:prstGeom>
+          <a:solidFill>
+            <a:srgbClr val="092010"/>
+          </a:solidFill>
+          <a:ln w="12700">
+            <a:solidFill>
+              <a:srgbClr val="3FB950"/>
+            </a:solidFill>
+          </a:ln>
+        </p:spPr>
+        <p:style>
+          <a:lnRef idx="1">
+            <a:schemeClr val="accent1"/>
+          </a:lnRef>
+          <a:fillRef idx="3">
+            <a:schemeClr val="accent1"/>
+          </a:fillRef>
+          <a:effectRef idx="2">
+            <a:schemeClr val="accent1"/>
+          </a:effectRef>
+          <a:fontRef idx="minor">
+            <a:schemeClr val="lt1"/>
+          </a:fontRef>
+        </p:style>
+        <p:txBody>
+          <a:bodyPr rtlCol="0" anchor="ctr"/>
+          <a:lstStyle/>
+          <a:p>
+            <a:pPr algn="ctr"/>
+          </a:p>
+        </p:txBody>
+      </p:sp>
+      <p:sp>
+        <p:nvSpPr>
+          <p:cNvPr id="61" name="TextBox 60"/>
+          <p:cNvSpPr txBox="1"/>
+          <p:nvPr/>
+        </p:nvSpPr>
+        <p:spPr>
+          <a:xfrm>
+            <a:off x="9454896" y="4160520"/>
+            <a:ext cx="2514600" cy="256032"/>
+          </a:xfrm>
+          <a:prstGeom prst="rect">
+            <a:avLst/>
+          </a:prstGeom>
+          <a:noFill/>
+        </p:spPr>
+        <p:txBody>
+          <a:bodyPr wrap="square">
+            <a:spAutoFit/>
+          </a:bodyPr>
+          <a:lstStyle/>
+          <a:p>
+            <a:pPr algn="l"/>
+            <a:r>
+              <a:rPr sz="800" b="0">
+                <a:solidFill>
+                  <a:srgbClr val="ADBAC7"/>
+                </a:solidFill>
+              </a:rPr>
+              <a:t>Tablas geográficas  (5)</a:t>
+            </a:r>
+          </a:p>
+        </p:txBody>
+      </p:sp>
+      <p:sp>
+        <p:nvSpPr>
+          <p:cNvPr id="62" name="Rectangle 61"/>
+          <p:cNvSpPr/>
+          <p:nvPr/>
+        </p:nvSpPr>
+        <p:spPr>
+          <a:xfrm>
+            <a:off x="9180576" y="4562856"/>
+            <a:ext cx="201168" cy="182880"/>
+          </a:xfrm>
+          <a:prstGeom prst="rect">
+            <a:avLst/>
+          </a:prstGeom>
+          <a:solidFill>
+            <a:srgbClr val="09142E"/>
+          </a:solidFill>
+          <a:ln w="12700">
+            <a:solidFill>
+              <a:srgbClr val="58A6FF"/>
+            </a:solidFill>
+          </a:ln>
+        </p:spPr>
+        <p:style>
+          <a:lnRef idx="1">
+            <a:schemeClr val="accent1"/>
+          </a:lnRef>
+          <a:fillRef idx="3">
+            <a:schemeClr val="accent1"/>
+          </a:fillRef>
+          <a:effectRef idx="2">
+            <a:schemeClr val="accent1"/>
+          </a:effectRef>
+          <a:fontRef idx="minor">
+            <a:schemeClr val="lt1"/>
+          </a:fontRef>
+        </p:style>
+        <p:txBody>
+          <a:bodyPr rtlCol="0" anchor="ctr"/>
+          <a:lstStyle/>
+          <a:p>
+            <a:pPr algn="ctr"/>
+          </a:p>
+        </p:txBody>
+      </p:sp>
+      <p:sp>
+        <p:nvSpPr>
+          <p:cNvPr id="63" name="TextBox 62"/>
+          <p:cNvSpPr txBox="1"/>
+          <p:nvPr/>
+        </p:nvSpPr>
+        <p:spPr>
+          <a:xfrm>
+            <a:off x="9454896" y="4526280"/>
+            <a:ext cx="2514600" cy="256032"/>
+          </a:xfrm>
+          <a:prstGeom prst="rect">
+            <a:avLst/>
+          </a:prstGeom>
+          <a:noFill/>
+        </p:spPr>
+        <p:txBody>
+          <a:bodyPr wrap="square">
+            <a:spAutoFit/>
+          </a:bodyPr>
+          <a:lstStyle/>
+          <a:p>
+            <a:pPr algn="l"/>
+            <a:r>
+              <a:rPr sz="800" b="0">
+                <a:solidFill>
+                  <a:srgbClr val="ADBAC7"/>
+                </a:solidFill>
+              </a:rPr>
+              <a:t>Fase 1 — principales  (7)</a:t>
+            </a:r>
+          </a:p>
+        </p:txBody>
+      </p:sp>
+      <p:sp>
+        <p:nvSpPr>
+          <p:cNvPr id="64" name="Rectangle 63"/>
+          <p:cNvSpPr/>
+          <p:nvPr/>
+        </p:nvSpPr>
+        <p:spPr>
+          <a:xfrm>
+            <a:off x="9180576" y="4928616"/>
+            <a:ext cx="201168" cy="182880"/>
+          </a:xfrm>
+          <a:prstGeom prst="rect">
+            <a:avLst/>
+          </a:prstGeom>
+          <a:solidFill>
+            <a:srgbClr val="18092E"/>
+          </a:solidFill>
+          <a:ln w="12700">
+            <a:solidFill>
+              <a:srgbClr val="BC8CFF"/>
+            </a:solidFill>
+          </a:ln>
+        </p:spPr>
+        <p:style>
+          <a:lnRef idx="1">
+            <a:schemeClr val="accent1"/>
+          </a:lnRef>
+          <a:fillRef idx="3">
+            <a:schemeClr val="accent1"/>
+          </a:fillRef>
+          <a:effectRef idx="2">
+            <a:schemeClr val="accent1"/>
+          </a:effectRef>
+          <a:fontRef idx="minor">
+            <a:schemeClr val="lt1"/>
+          </a:fontRef>
+        </p:style>
+        <p:txBody>
+          <a:bodyPr rtlCol="0" anchor="ctr"/>
+          <a:lstStyle/>
+          <a:p>
+            <a:pPr algn="ctr"/>
+          </a:p>
+        </p:txBody>
+      </p:sp>
+      <p:sp>
+        <p:nvSpPr>
+          <p:cNvPr id="65" name="TextBox 64"/>
+          <p:cNvSpPr txBox="1"/>
+          <p:nvPr/>
+        </p:nvSpPr>
+        <p:spPr>
+          <a:xfrm>
+            <a:off x="9454896" y="4892040"/>
+            <a:ext cx="2514600" cy="256032"/>
+          </a:xfrm>
+          <a:prstGeom prst="rect">
+            <a:avLst/>
+          </a:prstGeom>
+          <a:noFill/>
+        </p:spPr>
+        <p:txBody>
+          <a:bodyPr wrap="square">
+            <a:spAutoFit/>
+          </a:bodyPr>
+          <a:lstStyle/>
+          <a:p>
+            <a:pPr algn="l"/>
+            <a:r>
+              <a:rPr sz="800" b="0">
+                <a:solidFill>
+                  <a:srgbClr val="ADBAC7"/>
+                </a:solidFill>
+              </a:rPr>
+              <a:t>Fase 2 — nuevas  (5)</a:t>
+            </a:r>
+          </a:p>
+        </p:txBody>
+      </p:sp>
+      <p:sp>
+        <p:nvSpPr>
+          <p:cNvPr id="66" name="Rectangle 65"/>
+          <p:cNvSpPr/>
+          <p:nvPr/>
+        </p:nvSpPr>
+        <p:spPr>
+          <a:xfrm>
+            <a:off x="9180576" y="5294376"/>
+            <a:ext cx="201168" cy="182880"/>
+          </a:xfrm>
+          <a:prstGeom prst="rect">
+            <a:avLst/>
+          </a:prstGeom>
+          <a:solidFill>
+            <a:srgbClr val="221205"/>
+          </a:solidFill>
+          <a:ln w="12700">
+            <a:solidFill>
+              <a:srgbClr val="FFA657"/>
+            </a:solidFill>
+          </a:ln>
+        </p:spPr>
+        <p:style>
+          <a:lnRef idx="1">
+            <a:schemeClr val="accent1"/>
+          </a:lnRef>
+          <a:fillRef idx="3">
+            <a:schemeClr val="accent1"/>
+          </a:fillRef>
+          <a:effectRef idx="2">
+            <a:schemeClr val="accent1"/>
+          </a:effectRef>
+          <a:fontRef idx="minor">
+            <a:schemeClr val="lt1"/>
+          </a:fontRef>
+        </p:style>
+        <p:txBody>
+          <a:bodyPr rtlCol="0" anchor="ctr"/>
+          <a:lstStyle/>
+          <a:p>
+            <a:pPr algn="ctr"/>
+          </a:p>
+        </p:txBody>
+      </p:sp>
+      <p:sp>
+        <p:nvSpPr>
+          <p:cNvPr id="67" name="TextBox 66"/>
+          <p:cNvSpPr txBox="1"/>
+          <p:nvPr/>
+        </p:nvSpPr>
+        <p:spPr>
+          <a:xfrm>
+            <a:off x="9454896" y="5257800"/>
+            <a:ext cx="2514600" cy="256032"/>
+          </a:xfrm>
+          <a:prstGeom prst="rect">
+            <a:avLst/>
+          </a:prstGeom>
+          <a:noFill/>
+        </p:spPr>
+        <p:txBody>
+          <a:bodyPr wrap="square">
+            <a:spAutoFit/>
+          </a:bodyPr>
+          <a:lstStyle/>
+          <a:p>
+            <a:pPr algn="l"/>
+            <a:r>
+              <a:rPr sz="800" b="0">
+                <a:solidFill>
+                  <a:srgbClr val="ADBAC7"/>
+                </a:solidFill>
+              </a:rPr>
+              <a:t>Sistema  (2)</a:t>
+            </a:r>
+          </a:p>
+        </p:txBody>
+      </p:sp>
+      <p:sp>
+        <p:nvSpPr>
+          <p:cNvPr id="68" name="TextBox 67"/>
+          <p:cNvSpPr txBox="1"/>
+          <p:nvPr/>
+        </p:nvSpPr>
+        <p:spPr>
+          <a:xfrm>
+            <a:off x="11091672" y="6492240"/>
+            <a:ext cx="1005840" cy="274320"/>
+          </a:xfrm>
+          <a:prstGeom prst="rect">
+            <a:avLst/>
+          </a:prstGeom>
+          <a:noFill/>
+        </p:spPr>
+        <p:txBody>
+          <a:bodyPr wrap="square">
+            <a:spAutoFit/>
+          </a:bodyPr>
+          <a:lstStyle/>
+          <a:p>
+            <a:pPr algn="r"/>
+            <a:r>
+              <a:rPr sz="900" b="0">
+                <a:solidFill>
+                  <a:srgbClr val="8B949E"/>
+                </a:solidFill>
+              </a:rPr>
+              <a:t>14 / 14</a:t>
             </a:r>
           </a:p>
         </p:txBody>
@@ -10539,7 +13175,7 @@
                   <a:srgbClr val="8B949E"/>
                 </a:solidFill>
               </a:rPr>
-              <a:t>2 / 13</a:t>
+              <a:t>2 / 14</a:t>
             </a:r>
           </a:p>
         </p:txBody>
@@ -11454,7 +14090,7 @@
                   <a:srgbClr val="8B949E"/>
                 </a:solidFill>
               </a:rPr>
-              <a:t>3 / 13</a:t>
+              <a:t>3 / 14</a:t>
             </a:r>
           </a:p>
         </p:txBody>
@@ -12577,7 +15213,7 @@
                   <a:srgbClr val="8B949E"/>
                 </a:solidFill>
               </a:rPr>
-              <a:t>4 / 13</a:t>
+              <a:t>4 / 14</a:t>
             </a:r>
           </a:p>
         </p:txBody>
@@ -13697,7 +16333,7 @@
                   <a:srgbClr val="8B949E"/>
                 </a:solidFill>
               </a:rPr>
-              <a:t>5 / 13</a:t>
+              <a:t>5 / 14</a:t>
             </a:r>
           </a:p>
         </p:txBody>
@@ -14376,7 +17012,7 @@
                   <a:srgbClr val="8B949E"/>
                 </a:solidFill>
               </a:rPr>
-              <a:t>6 / 13</a:t>
+              <a:t>6 / 14</a:t>
             </a:r>
           </a:p>
         </p:txBody>
@@ -15622,7 +18258,7 @@
                   <a:srgbClr val="8B949E"/>
                 </a:solidFill>
               </a:rPr>
-              <a:t>7 / 13</a:t>
+              <a:t>7 / 14</a:t>
             </a:r>
           </a:p>
         </p:txBody>
@@ -16704,7 +19340,7 @@
                   <a:srgbClr val="8B949E"/>
                 </a:solidFill>
               </a:rPr>
-              <a:t>8 / 13</a:t>
+              <a:t>8 / 14</a:t>
             </a:r>
           </a:p>
         </p:txBody>
@@ -18247,7 +20883,7 @@
                   <a:srgbClr val="8B949E"/>
                 </a:solidFill>
               </a:rPr>
-              <a:t>9 / 13</a:t>
+              <a:t>9 / 14</a:t>
             </a:r>
           </a:p>
         </p:txBody>

</xml_diff>